<commit_message>
Dagger alif drawn as a small red alif above the letter (U+0670), not beside it; Quranic marks use Traditional Arabic in the madd decks
Arial has no head-of-khaa sukun, so sentences such as خَيۡرٌ showed empty boxes.

Co-Authored-By: Claude Opus 5.5 <noreply@anthropic.com>
Claude-Session: https://claude.ai/code/session_01XjTEwQ8YdBa1SjcPiYTm9z
</commit_message>
<xml_diff>
--- a/madd-plus/waw/01-alif.pptx
+++ b/madd-plus/waw/01-alif.pptx
@@ -25240,9 +25240,9 @@
                 <a:solidFill>
                   <a:srgbClr val="16213E"/>
                 </a:solidFill>
-                <a:latin typeface="Arial" pitchFamily="34" charset="0"/>
-                <a:ea typeface="Arial" pitchFamily="34" charset="-122"/>
-                <a:cs typeface="Arial" pitchFamily="34" charset="-120"/>
+                <a:latin typeface="Traditional Arabic" pitchFamily="34" charset="0"/>
+                <a:ea typeface="Traditional Arabic" pitchFamily="34" charset="-122"/>
+                <a:cs typeface="Traditional Arabic" pitchFamily="34" charset="-120"/>
               </a:rPr>
               <a:t>عِلۡمًا</a:t>
             </a:r>
@@ -25331,9 +25331,9 @@
                 <a:solidFill>
                   <a:srgbClr val="16213E"/>
                 </a:solidFill>
-                <a:latin typeface="Arial" pitchFamily="34" charset="0"/>
-                <a:ea typeface="Arial" pitchFamily="34" charset="-122"/>
-                <a:cs typeface="Arial" pitchFamily="34" charset="-120"/>
+                <a:latin typeface="Traditional Arabic" pitchFamily="34" charset="0"/>
+                <a:ea typeface="Traditional Arabic" pitchFamily="34" charset="-122"/>
+                <a:cs typeface="Traditional Arabic" pitchFamily="34" charset="-120"/>
               </a:rPr>
               <a:t>أُوتِيَ عِلۡمًا</a:t>
             </a:r>
@@ -26102,9 +26102,9 @@
                 <a:solidFill>
                   <a:srgbClr val="16213E"/>
                 </a:solidFill>
-                <a:latin typeface="Arial" pitchFamily="34" charset="0"/>
-                <a:ea typeface="Arial" pitchFamily="34" charset="-122"/>
-                <a:cs typeface="Arial" pitchFamily="34" charset="-120"/>
+                <a:latin typeface="Traditional Arabic" pitchFamily="34" charset="0"/>
+                <a:ea typeface="Traditional Arabic" pitchFamily="34" charset="-122"/>
+                <a:cs typeface="Traditional Arabic" pitchFamily="34" charset="-120"/>
               </a:rPr>
               <a:t>يَأۡكُلُونَ</a:t>
             </a:r>
@@ -26168,9 +26168,9 @@
                 <a:solidFill>
                   <a:srgbClr val="16213E"/>
                 </a:solidFill>
-                <a:latin typeface="Arial" pitchFamily="34" charset="0"/>
-                <a:ea typeface="Arial" pitchFamily="34" charset="-122"/>
-                <a:cs typeface="Arial" pitchFamily="34" charset="-120"/>
+                <a:latin typeface="Traditional Arabic" pitchFamily="34" charset="0"/>
+                <a:ea typeface="Traditional Arabic" pitchFamily="34" charset="-122"/>
+                <a:cs typeface="Traditional Arabic" pitchFamily="34" charset="-120"/>
               </a:rPr>
               <a:t>وَيَشۡرَبُونَ</a:t>
             </a:r>
@@ -26259,9 +26259,9 @@
                 <a:solidFill>
                   <a:srgbClr val="16213E"/>
                 </a:solidFill>
-                <a:latin typeface="Arial" pitchFamily="34" charset="0"/>
-                <a:ea typeface="Arial" pitchFamily="34" charset="-122"/>
-                <a:cs typeface="Arial" pitchFamily="34" charset="-120"/>
+                <a:latin typeface="Traditional Arabic" pitchFamily="34" charset="0"/>
+                <a:ea typeface="Traditional Arabic" pitchFamily="34" charset="-122"/>
+                <a:cs typeface="Traditional Arabic" pitchFamily="34" charset="-120"/>
               </a:rPr>
               <a:t>يَأۡكُلُونَ وَيَشۡرَبُونَ</a:t>
             </a:r>

</xml_diff>